<commit_message>
Mettre a jour le rendu PowerPoint
</commit_message>
<xml_diff>
--- a/rendu_visualisation.pptx
+++ b/rendu_visualisation.pptx
@@ -104,6 +104,11 @@
       </a:defRPr>
     </a:lvl9pPr>
   </p:defaultTextStyle>
+  <p:extLst>
+    <p:ext uri="{EFAFB233-063F-42B5-8137-9DF3F51BA10A}">
+      <p15:sldGuideLst xmlns:p15="http://schemas.microsoft.com/office/powerpoint/2012/main"/>
+    </p:ext>
+  </p:extLst>
 </p:presentation>
 </file>
 
@@ -3373,10 +3378,10 @@
       </p:sp>
       <p:pic>
         <p:nvPicPr>
-          <p:cNvPr id="5" name="Image 4">
-            <a:extLst>
-              <a:ext uri="{FF2B5EF4-FFF2-40B4-BE49-F238E27FC236}">
-                <a16:creationId xmlns:a16="http://schemas.microsoft.com/office/drawing/2014/main" id="{125DBD9F-1DDD-42CB-83CE-C37FD983566C}"/>
+          <p:cNvPr id="6" name="Image 5">
+            <a:extLst>
+              <a:ext uri="{FF2B5EF4-FFF2-40B4-BE49-F238E27FC236}">
+                <a16:creationId xmlns:a16="http://schemas.microsoft.com/office/drawing/2014/main" id="{65FAB1F0-4E83-A9A4-0C21-6166D0932A08}"/>
               </a:ext>
             </a:extLst>
           </p:cNvPr>
@@ -3399,8 +3404,8 @@
         </p:blipFill>
         <p:spPr>
           <a:xfrm>
-            <a:off x="0" y="190514"/>
-            <a:ext cx="12192000" cy="6557653"/>
+            <a:off x="0" y="141638"/>
+            <a:ext cx="12192000" cy="6574724"/>
           </a:xfrm>
           <a:prstGeom prst="rect">
             <a:avLst/>

</xml_diff>